<commit_message>
Day 2 deck: Where the Money Is hows with more context; warranty band without the dollar figure
Co-Authored-By: Claude Opus 5.5 <noreply@anthropic.com>
Claude-Session: https://claude.ai/code/session_01Xa4nFVxuQGXmHARGph9WhS
</commit_message>
<xml_diff>
--- a/day2-deck/decks/Warranty Audits - Draft.pptx
+++ b/day2-deck/decks/Warranty Audits - Draft.pptx
@@ -4341,7 +4341,7 @@
         <p:spPr>
           <a:xfrm>
             <a:off x="457200" y="6126480"/>
-            <a:ext cx="11274552" cy="615696"/>
+            <a:ext cx="11274552" cy="371856"/>
           </a:xfrm>
           <a:prstGeom prst="rect">
             <a:avLst/>
@@ -4361,7 +4361,7 @@
         <p:spPr>
           <a:xfrm>
             <a:off x="658368" y="6144768"/>
-            <a:ext cx="10927080" cy="579120"/>
+            <a:ext cx="10927080" cy="335280"/>
           </a:xfrm>
           <a:prstGeom prst="rect">
             <a:avLst/>
@@ -4385,7 +4385,7 @@
                 <a:ea typeface="Inter" pitchFamily="34" charset="-122"/>
                 <a:cs typeface="Inter" pitchFamily="34" charset="-120"/>
               </a:rPr>
-              <a:t>$3,788,200 added by rate increases at 19 stores this year. Protect it: higher rates draw more audits, so document every claim to hold up.</a:t>
+              <a:t>Protect that money: higher rates draw more audits, so document every claim to hold up.</a:t>
             </a:r>
             <a:endParaRPr lang="en-US" sz="1600" dirty="0"/>
           </a:p>

</xml_diff>